<commit_message>
Collapse quadrant rule and fix palette on formula/example headers
- Quadrant Adjustment slide (new #9): drop the four-row example table
  in favor of the single compact rule from HANDOFF §3.8 -
  alpha = tan^-1(b/a), then if a<0 add 180, else if b<0 add 360,
  otherwise keep alpha.
- Component Form slide (#5): "Formula:" header now TEAL (definition),
  "Example:" header now ORANGE (worked problem).
- Magnitude and Direction slide (#8): same swap - "Direction:" moves
  to TEAL alongside "Magnitude:", "Example:" moves to ORANGE.

Both slides now match the semantic palette in HANDOFF §3.9.

https://claude.ai/code/session_01Be6pun3kUQWZDaFSghJVz1
</commit_message>
<xml_diff>
--- a/slides/Math130Unit3D.pptx
+++ b/slides/Math130Unit3D.pptx
@@ -5698,7 +5698,7 @@
             <a:r>
               <a:rPr lang="en-US" sz="1400" b="1" dirty="0">
                 <a:solidFill>
-                  <a:srgbClr val="F97316"/>
+                  <a:srgbClr val="0891B2"/>
                 </a:solidFill>
                 <a:latin typeface="Georgia" pitchFamily="34" charset="0"/>
                 <a:ea typeface="Georgia" pitchFamily="34" charset="-122"/>
@@ -5781,7 +5781,7 @@
             <a:r>
               <a:rPr lang="en-US" sz="1500" b="1" dirty="0">
                 <a:solidFill>
-                  <a:srgbClr val="0891B2"/>
+                  <a:srgbClr val="F97316"/>
                 </a:solidFill>
                 <a:latin typeface="Georgia" pitchFamily="34" charset="0"/>
                 <a:ea typeface="Georgia" pitchFamily="34" charset="-122"/>
@@ -7070,7 +7070,7 @@
             <a:r>
               <a:rPr lang="en-US" sz="1600" b="1" dirty="0">
                 <a:solidFill>
-                  <a:srgbClr val="F97316"/>
+                  <a:srgbClr val="0891B2"/>
                 </a:solidFill>
                 <a:latin typeface="Georgia" pitchFamily="34" charset="0"/>
                 <a:ea typeface="Georgia" pitchFamily="34" charset="-122"/>
@@ -7406,485 +7406,15 @@
               <a:buNone/>
             </a:pPr>
             <a:r>
-              <a:rPr lang="en-US" sz="1700" b="1" dirty="0">
+              <a:rPr sz="2000" b="1">
                 <a:solidFill>
                   <a:srgbClr val="1E3A5F"/>
                 </a:solidFill>
-                <a:latin typeface="Georgia" pitchFamily="34" charset="0"/>
-                <a:ea typeface="Georgia" pitchFamily="34" charset="-122"/>
-                <a:cs typeface="Georgia" pitchFamily="34" charset="-120"/>
-              </a:rPr>
-              <a:t>Examples</a:t>
+                <a:latin typeface="Georgia"/>
+              </a:rPr>
+              <a:t>One Rule for θ</a:t>
             </a:r>
             <a:endParaRPr lang="en-US" sz="1700" dirty="0"/>
-          </a:p>
-        </p:txBody>
-      </p:sp>
-      <p:sp>
-        <p:nvSpPr>
-          <p:cNvPr id="6" name="Text 3"/>
-          <p:cNvSpPr/>
-          <p:nvPr/>
-        </p:nvSpPr>
-        <p:spPr>
-          <a:xfrm>
-            <a:off x="5212080" y="1463040"/>
-            <a:ext cx="1371600" cy="228600"/>
-          </a:xfrm>
-          <a:prstGeom prst="rect">
-            <a:avLst/>
-          </a:prstGeom>
-          <a:noFill/>
-          <a:ln/>
-        </p:spPr>
-        <p:txBody>
-          <a:bodyPr wrap="square" lIns="0" tIns="0" rIns="0" bIns="0" rtlCol="0" anchor="ctr"/>
-          <a:lstStyle/>
-          <a:p>
-            <a:pPr indent="0" marL="0">
-              <a:buNone/>
-            </a:pPr>
-            <a:r>
-              <a:rPr lang="en-US" sz="1300" b="1" dirty="0">
-                <a:solidFill>
-                  <a:srgbClr val="0891B2"/>
-                </a:solidFill>
-                <a:latin typeface="Georgia" pitchFamily="34" charset="0"/>
-                <a:ea typeface="Georgia" pitchFamily="34" charset="-122"/>
-                <a:cs typeface="Georgia" pitchFamily="34" charset="-120"/>
-              </a:rPr>
-              <a:t>⟨3, 4⟩</a:t>
-            </a:r>
-            <a:endParaRPr lang="en-US" sz="1300" dirty="0"/>
-          </a:p>
-        </p:txBody>
-      </p:sp>
-      <p:sp>
-        <p:nvSpPr>
-          <p:cNvPr id="7" name="Text 4"/>
-          <p:cNvSpPr/>
-          <p:nvPr/>
-        </p:nvSpPr>
-        <p:spPr>
-          <a:xfrm>
-            <a:off x="6583680" y="1463040"/>
-            <a:ext cx="548640" cy="228600"/>
-          </a:xfrm>
-          <a:prstGeom prst="rect">
-            <a:avLst/>
-          </a:prstGeom>
-          <a:noFill/>
-          <a:ln/>
-        </p:spPr>
-        <p:txBody>
-          <a:bodyPr wrap="square" lIns="0" tIns="0" rIns="0" bIns="0" rtlCol="0" anchor="ctr"/>
-          <a:lstStyle/>
-          <a:p>
-            <a:pPr indent="0" marL="0">
-              <a:buNone/>
-            </a:pPr>
-            <a:r>
-              <a:rPr lang="en-US" sz="1200" dirty="0">
-                <a:solidFill>
-                  <a:srgbClr val="64748B"/>
-                </a:solidFill>
-                <a:latin typeface="Calibri" pitchFamily="34" charset="0"/>
-                <a:ea typeface="Calibri" pitchFamily="34" charset="-122"/>
-                <a:cs typeface="Calibri" pitchFamily="34" charset="-120"/>
-              </a:rPr>
-              <a:t>Q I</a:t>
-            </a:r>
-            <a:endParaRPr lang="en-US" sz="1200" dirty="0"/>
-          </a:p>
-        </p:txBody>
-      </p:sp>
-      <p:sp>
-        <p:nvSpPr>
-          <p:cNvPr id="8" name="Text 5"/>
-          <p:cNvSpPr/>
-          <p:nvPr/>
-        </p:nvSpPr>
-        <p:spPr>
-          <a:xfrm>
-            <a:off x="5212080" y="1737360"/>
-            <a:ext cx="3200400" cy="274320"/>
-          </a:xfrm>
-          <a:prstGeom prst="rect">
-            <a:avLst/>
-          </a:prstGeom>
-          <a:noFill/>
-          <a:ln/>
-        </p:spPr>
-        <p:txBody>
-          <a:bodyPr wrap="square" lIns="0" tIns="0" rIns="0" bIns="0" rtlCol="0" anchor="ctr"/>
-          <a:lstStyle/>
-          <a:p>
-            <a:pPr indent="0" marL="0">
-              <a:buNone/>
-            </a:pPr>
-            <a:r>
-              <a:rPr lang="en-US" sz="1400" b="1" dirty="0">
-                <a:solidFill>
-                  <a:srgbClr val="0891B2"/>
-                </a:solidFill>
-                <a:latin typeface="Calibri" pitchFamily="34" charset="0"/>
-                <a:ea typeface="Calibri" pitchFamily="34" charset="-122"/>
-                <a:cs typeface="Calibri" pitchFamily="34" charset="-120"/>
-              </a:rPr>
-              <a:t>θ ≈ 53.1°</a:t>
-            </a:r>
-            <a:endParaRPr lang="en-US" sz="1400" dirty="0"/>
-          </a:p>
-        </p:txBody>
-      </p:sp>
-      <p:sp>
-        <p:nvSpPr>
-          <p:cNvPr id="9" name="Text 6"/>
-          <p:cNvSpPr/>
-          <p:nvPr/>
-        </p:nvSpPr>
-        <p:spPr>
-          <a:xfrm>
-            <a:off x="5212080" y="2240280"/>
-            <a:ext cx="1371600" cy="228600"/>
-          </a:xfrm>
-          <a:prstGeom prst="rect">
-            <a:avLst/>
-          </a:prstGeom>
-          <a:noFill/>
-          <a:ln/>
-        </p:spPr>
-        <p:txBody>
-          <a:bodyPr wrap="square" lIns="0" tIns="0" rIns="0" bIns="0" rtlCol="0" anchor="ctr"/>
-          <a:lstStyle/>
-          <a:p>
-            <a:pPr indent="0" marL="0">
-              <a:buNone/>
-            </a:pPr>
-            <a:r>
-              <a:rPr lang="en-US" sz="1300" b="1" dirty="0">
-                <a:solidFill>
-                  <a:srgbClr val="7C3AED"/>
-                </a:solidFill>
-                <a:latin typeface="Georgia" pitchFamily="34" charset="0"/>
-                <a:ea typeface="Georgia" pitchFamily="34" charset="-122"/>
-                <a:cs typeface="Georgia" pitchFamily="34" charset="-120"/>
-              </a:rPr>
-              <a:t>⟨−5, 12⟩</a:t>
-            </a:r>
-            <a:endParaRPr lang="en-US" sz="1300" dirty="0"/>
-          </a:p>
-        </p:txBody>
-      </p:sp>
-      <p:sp>
-        <p:nvSpPr>
-          <p:cNvPr id="10" name="Text 7"/>
-          <p:cNvSpPr/>
-          <p:nvPr/>
-        </p:nvSpPr>
-        <p:spPr>
-          <a:xfrm>
-            <a:off x="6583680" y="2240280"/>
-            <a:ext cx="548640" cy="228600"/>
-          </a:xfrm>
-          <a:prstGeom prst="rect">
-            <a:avLst/>
-          </a:prstGeom>
-          <a:noFill/>
-          <a:ln/>
-        </p:spPr>
-        <p:txBody>
-          <a:bodyPr wrap="square" lIns="0" tIns="0" rIns="0" bIns="0" rtlCol="0" anchor="ctr"/>
-          <a:lstStyle/>
-          <a:p>
-            <a:pPr indent="0" marL="0">
-              <a:buNone/>
-            </a:pPr>
-            <a:r>
-              <a:rPr lang="en-US" sz="1200" dirty="0">
-                <a:solidFill>
-                  <a:srgbClr val="64748B"/>
-                </a:solidFill>
-                <a:latin typeface="Calibri" pitchFamily="34" charset="0"/>
-                <a:ea typeface="Calibri" pitchFamily="34" charset="-122"/>
-                <a:cs typeface="Calibri" pitchFamily="34" charset="-120"/>
-              </a:rPr>
-              <a:t>Q II</a:t>
-            </a:r>
-            <a:endParaRPr lang="en-US" sz="1200" dirty="0"/>
-          </a:p>
-        </p:txBody>
-      </p:sp>
-      <p:sp>
-        <p:nvSpPr>
-          <p:cNvPr id="11" name="Text 8"/>
-          <p:cNvSpPr/>
-          <p:nvPr/>
-        </p:nvSpPr>
-        <p:spPr>
-          <a:xfrm>
-            <a:off x="5212080" y="2514600"/>
-            <a:ext cx="3200400" cy="274320"/>
-          </a:xfrm>
-          <a:prstGeom prst="rect">
-            <a:avLst/>
-          </a:prstGeom>
-          <a:noFill/>
-          <a:ln/>
-        </p:spPr>
-        <p:txBody>
-          <a:bodyPr wrap="square" lIns="0" tIns="0" rIns="0" bIns="0" rtlCol="0" anchor="ctr"/>
-          <a:lstStyle/>
-          <a:p>
-            <a:pPr indent="0" marL="0">
-              <a:buNone/>
-            </a:pPr>
-            <a:r>
-              <a:rPr lang="en-US" sz="1400" b="1" dirty="0">
-                <a:solidFill>
-                  <a:srgbClr val="7C3AED"/>
-                </a:solidFill>
-                <a:latin typeface="Calibri" pitchFamily="34" charset="0"/>
-                <a:ea typeface="Calibri" pitchFamily="34" charset="-122"/>
-                <a:cs typeface="Calibri" pitchFamily="34" charset="-120"/>
-              </a:rPr>
-              <a:t>θ ≈ 112.6°</a:t>
-            </a:r>
-            <a:endParaRPr lang="en-US" sz="1400" dirty="0"/>
-          </a:p>
-        </p:txBody>
-      </p:sp>
-      <p:sp>
-        <p:nvSpPr>
-          <p:cNvPr id="12" name="Text 9"/>
-          <p:cNvSpPr/>
-          <p:nvPr/>
-        </p:nvSpPr>
-        <p:spPr>
-          <a:xfrm>
-            <a:off x="5212080" y="3017520"/>
-            <a:ext cx="1371600" cy="228600"/>
-          </a:xfrm>
-          <a:prstGeom prst="rect">
-            <a:avLst/>
-          </a:prstGeom>
-          <a:noFill/>
-          <a:ln/>
-        </p:spPr>
-        <p:txBody>
-          <a:bodyPr wrap="square" lIns="0" tIns="0" rIns="0" bIns="0" rtlCol="0" anchor="ctr"/>
-          <a:lstStyle/>
-          <a:p>
-            <a:pPr indent="0" marL="0">
-              <a:buNone/>
-            </a:pPr>
-            <a:r>
-              <a:rPr lang="en-US" sz="1300" b="1" dirty="0">
-                <a:solidFill>
-                  <a:srgbClr val="DC2626"/>
-                </a:solidFill>
-                <a:latin typeface="Georgia" pitchFamily="34" charset="0"/>
-                <a:ea typeface="Georgia" pitchFamily="34" charset="-122"/>
-                <a:cs typeface="Georgia" pitchFamily="34" charset="-120"/>
-              </a:rPr>
-              <a:t>⟨−3, −7⟩</a:t>
-            </a:r>
-            <a:endParaRPr lang="en-US" sz="1300" dirty="0"/>
-          </a:p>
-        </p:txBody>
-      </p:sp>
-      <p:sp>
-        <p:nvSpPr>
-          <p:cNvPr id="13" name="Text 10"/>
-          <p:cNvSpPr/>
-          <p:nvPr/>
-        </p:nvSpPr>
-        <p:spPr>
-          <a:xfrm>
-            <a:off x="6583680" y="3017520"/>
-            <a:ext cx="548640" cy="228600"/>
-          </a:xfrm>
-          <a:prstGeom prst="rect">
-            <a:avLst/>
-          </a:prstGeom>
-          <a:noFill/>
-          <a:ln/>
-        </p:spPr>
-        <p:txBody>
-          <a:bodyPr wrap="square" lIns="0" tIns="0" rIns="0" bIns="0" rtlCol="0" anchor="ctr"/>
-          <a:lstStyle/>
-          <a:p>
-            <a:pPr indent="0" marL="0">
-              <a:buNone/>
-            </a:pPr>
-            <a:r>
-              <a:rPr lang="en-US" sz="1200" dirty="0">
-                <a:solidFill>
-                  <a:srgbClr val="64748B"/>
-                </a:solidFill>
-                <a:latin typeface="Calibri" pitchFamily="34" charset="0"/>
-                <a:ea typeface="Calibri" pitchFamily="34" charset="-122"/>
-                <a:cs typeface="Calibri" pitchFamily="34" charset="-120"/>
-              </a:rPr>
-              <a:t>Q III</a:t>
-            </a:r>
-            <a:endParaRPr lang="en-US" sz="1200" dirty="0"/>
-          </a:p>
-        </p:txBody>
-      </p:sp>
-      <p:sp>
-        <p:nvSpPr>
-          <p:cNvPr id="14" name="Text 11"/>
-          <p:cNvSpPr/>
-          <p:nvPr/>
-        </p:nvSpPr>
-        <p:spPr>
-          <a:xfrm>
-            <a:off x="5212080" y="3291840"/>
-            <a:ext cx="3200400" cy="274320"/>
-          </a:xfrm>
-          <a:prstGeom prst="rect">
-            <a:avLst/>
-          </a:prstGeom>
-          <a:noFill/>
-          <a:ln/>
-        </p:spPr>
-        <p:txBody>
-          <a:bodyPr wrap="square" lIns="0" tIns="0" rIns="0" bIns="0" rtlCol="0" anchor="ctr"/>
-          <a:lstStyle/>
-          <a:p>
-            <a:pPr indent="0" marL="0">
-              <a:buNone/>
-            </a:pPr>
-            <a:r>
-              <a:rPr lang="en-US" sz="1400" b="1" dirty="0">
-                <a:solidFill>
-                  <a:srgbClr val="DC2626"/>
-                </a:solidFill>
-                <a:latin typeface="Calibri" pitchFamily="34" charset="0"/>
-                <a:ea typeface="Calibri" pitchFamily="34" charset="-122"/>
-                <a:cs typeface="Calibri" pitchFamily="34" charset="-120"/>
-              </a:rPr>
-              <a:t>θ ≈ 246.8°</a:t>
-            </a:r>
-            <a:endParaRPr lang="en-US" sz="1400" dirty="0"/>
-          </a:p>
-        </p:txBody>
-      </p:sp>
-      <p:sp>
-        <p:nvSpPr>
-          <p:cNvPr id="15" name="Text 12"/>
-          <p:cNvSpPr/>
-          <p:nvPr/>
-        </p:nvSpPr>
-        <p:spPr>
-          <a:xfrm>
-            <a:off x="5212080" y="3794760"/>
-            <a:ext cx="1371600" cy="228600"/>
-          </a:xfrm>
-          <a:prstGeom prst="rect">
-            <a:avLst/>
-          </a:prstGeom>
-          <a:noFill/>
-          <a:ln/>
-        </p:spPr>
-        <p:txBody>
-          <a:bodyPr wrap="square" lIns="0" tIns="0" rIns="0" bIns="0" rtlCol="0" anchor="ctr"/>
-          <a:lstStyle/>
-          <a:p>
-            <a:pPr indent="0" marL="0">
-              <a:buNone/>
-            </a:pPr>
-            <a:r>
-              <a:rPr lang="en-US" sz="1300" b="1" dirty="0">
-                <a:solidFill>
-                  <a:srgbClr val="F97316"/>
-                </a:solidFill>
-                <a:latin typeface="Georgia" pitchFamily="34" charset="0"/>
-                <a:ea typeface="Georgia" pitchFamily="34" charset="-122"/>
-                <a:cs typeface="Georgia" pitchFamily="34" charset="-120"/>
-              </a:rPr>
-              <a:t>⟨4, −2⟩</a:t>
-            </a:r>
-            <a:endParaRPr lang="en-US" sz="1300" dirty="0"/>
-          </a:p>
-        </p:txBody>
-      </p:sp>
-      <p:sp>
-        <p:nvSpPr>
-          <p:cNvPr id="16" name="Text 13"/>
-          <p:cNvSpPr/>
-          <p:nvPr/>
-        </p:nvSpPr>
-        <p:spPr>
-          <a:xfrm>
-            <a:off x="6583680" y="3794760"/>
-            <a:ext cx="548640" cy="228600"/>
-          </a:xfrm>
-          <a:prstGeom prst="rect">
-            <a:avLst/>
-          </a:prstGeom>
-          <a:noFill/>
-          <a:ln/>
-        </p:spPr>
-        <p:txBody>
-          <a:bodyPr wrap="square" lIns="0" tIns="0" rIns="0" bIns="0" rtlCol="0" anchor="ctr"/>
-          <a:lstStyle/>
-          <a:p>
-            <a:pPr indent="0" marL="0">
-              <a:buNone/>
-            </a:pPr>
-            <a:r>
-              <a:rPr lang="en-US" sz="1200" dirty="0">
-                <a:solidFill>
-                  <a:srgbClr val="64748B"/>
-                </a:solidFill>
-                <a:latin typeface="Calibri" pitchFamily="34" charset="0"/>
-                <a:ea typeface="Calibri" pitchFamily="34" charset="-122"/>
-                <a:cs typeface="Calibri" pitchFamily="34" charset="-120"/>
-              </a:rPr>
-              <a:t>Q IV</a:t>
-            </a:r>
-            <a:endParaRPr lang="en-US" sz="1200" dirty="0"/>
-          </a:p>
-        </p:txBody>
-      </p:sp>
-      <p:sp>
-        <p:nvSpPr>
-          <p:cNvPr id="17" name="Text 14"/>
-          <p:cNvSpPr/>
-          <p:nvPr/>
-        </p:nvSpPr>
-        <p:spPr>
-          <a:xfrm>
-            <a:off x="5212080" y="4069080"/>
-            <a:ext cx="3200400" cy="274320"/>
-          </a:xfrm>
-          <a:prstGeom prst="rect">
-            <a:avLst/>
-          </a:prstGeom>
-          <a:noFill/>
-          <a:ln/>
-        </p:spPr>
-        <p:txBody>
-          <a:bodyPr wrap="square" lIns="0" tIns="0" rIns="0" bIns="0" rtlCol="0" anchor="ctr"/>
-          <a:lstStyle/>
-          <a:p>
-            <a:pPr indent="0" marL="0">
-              <a:buNone/>
-            </a:pPr>
-            <a:r>
-              <a:rPr lang="en-US" sz="1400" b="1" dirty="0">
-                <a:solidFill>
-                  <a:srgbClr val="F97316"/>
-                </a:solidFill>
-                <a:latin typeface="Calibri" pitchFamily="34" charset="0"/>
-                <a:ea typeface="Calibri" pitchFamily="34" charset="-122"/>
-                <a:cs typeface="Calibri" pitchFamily="34" charset="-120"/>
-              </a:rPr>
-              <a:t>θ ≈ 333.4°</a:t>
-            </a:r>
-            <a:endParaRPr lang="en-US" sz="1400" dirty="0"/>
           </a:p>
         </p:txBody>
       </p:sp>
@@ -7912,6 +7442,139 @@
           </a:prstGeom>
         </p:spPr>
       </p:pic>
+      <p:sp>
+        <p:nvSpPr>
+          <p:cNvPr id="19" name="TextBox 18"/>
+          <p:cNvSpPr txBox="1"/>
+          <p:nvPr/>
+        </p:nvSpPr>
+        <p:spPr>
+          <a:xfrm>
+            <a:off x="5212080" y="1463040"/>
+            <a:ext cx="3657600" cy="2925000"/>
+          </a:xfrm>
+          <a:prstGeom prst="rect">
+            <a:avLst/>
+          </a:prstGeom>
+          <a:noFill/>
+        </p:spPr>
+        <p:txBody>
+          <a:bodyPr wrap="square">
+            <a:spAutoFit/>
+          </a:bodyPr>
+          <a:lstStyle/>
+          <a:p>
+            <a:r>
+              <a:rPr sz="1600" b="0">
+                <a:solidFill>
+                  <a:srgbClr val="1E3A5F"/>
+                </a:solidFill>
+                <a:latin typeface="Calibri"/>
+              </a:rPr>
+              <a:t>Compute α = tan⁻¹(b/a), then:</a:t>
+            </a:r>
+          </a:p>
+          <a:p>
+            <a:r>
+              <a:rPr sz="1000" b="0">
+                <a:solidFill>
+                  <a:srgbClr val="1E3A5F"/>
+                </a:solidFill>
+                <a:latin typeface="Calibri"/>
+              </a:rPr>
+              <a:t> </a:t>
+            </a:r>
+          </a:p>
+          <a:p>
+            <a:r>
+              <a:rPr sz="1600" b="1">
+                <a:solidFill>
+                  <a:srgbClr val="7C3AED"/>
+                </a:solidFill>
+                <a:latin typeface="Calibri"/>
+              </a:rPr>
+              <a:t>if a &lt; 0  →  θ = α + 180°</a:t>
+            </a:r>
+          </a:p>
+          <a:p>
+            <a:r>
+              <a:rPr sz="1300" b="0">
+                <a:solidFill>
+                  <a:srgbClr val="64748B"/>
+                </a:solidFill>
+                <a:latin typeface="Calibri"/>
+              </a:rPr>
+              <a:t>     (Q II or Q III)</a:t>
+            </a:r>
+          </a:p>
+          <a:p>
+            <a:r>
+              <a:rPr sz="1000" b="0">
+                <a:solidFill>
+                  <a:srgbClr val="1E3A5F"/>
+                </a:solidFill>
+                <a:latin typeface="Calibri"/>
+              </a:rPr>
+              <a:t> </a:t>
+            </a:r>
+          </a:p>
+          <a:p>
+            <a:r>
+              <a:rPr sz="1600" b="1">
+                <a:solidFill>
+                  <a:srgbClr val="7C3AED"/>
+                </a:solidFill>
+                <a:latin typeface="Calibri"/>
+              </a:rPr>
+              <a:t>else if b &lt; 0  →  θ = α + 360°</a:t>
+            </a:r>
+          </a:p>
+          <a:p>
+            <a:r>
+              <a:rPr sz="1300" b="0">
+                <a:solidFill>
+                  <a:srgbClr val="64748B"/>
+                </a:solidFill>
+                <a:latin typeface="Calibri"/>
+              </a:rPr>
+              <a:t>     (Q IV)</a:t>
+            </a:r>
+          </a:p>
+          <a:p>
+            <a:r>
+              <a:rPr sz="1000" b="0">
+                <a:solidFill>
+                  <a:srgbClr val="1E3A5F"/>
+                </a:solidFill>
+                <a:latin typeface="Calibri"/>
+              </a:rPr>
+              <a:t> </a:t>
+            </a:r>
+          </a:p>
+          <a:p>
+            <a:r>
+              <a:rPr sz="1600" b="1">
+                <a:solidFill>
+                  <a:srgbClr val="7C3AED"/>
+                </a:solidFill>
+                <a:latin typeface="Calibri"/>
+              </a:rPr>
+              <a:t>otherwise  →  θ = α</a:t>
+            </a:r>
+          </a:p>
+          <a:p>
+            <a:r>
+              <a:rPr sz="1300" b="0">
+                <a:solidFill>
+                  <a:srgbClr val="64748B"/>
+                </a:solidFill>
+                <a:latin typeface="Calibri"/>
+              </a:rPr>
+              <a:t>     (Q I)</a:t>
+            </a:r>
+          </a:p>
+        </p:txBody>
+      </p:sp>
     </p:spTree>
   </p:cSld>
   <p:clrMapOvr>

</xml_diff>